<commit_message>
Fix overlapping text in both defense decks
Text sized for the narrow Rajdhani and auto-shrink overflowed on viewers
without the font (e.g. phones). Resize overflowing boxes to fit a
standard-width fallback font and keep sizes consistent within each group.

Co-Authored-By: Claude Opus 5.5 <noreply@anthropic.com>
Claude-Session: https://claude.ai/code/session_017LCm8j33kEFXTvQ6u8C6h8
</commit_message>
<xml_diff>
--- a/slides/Ctrl-Think-Short-Defense_updated.pptx
+++ b/slides/Ctrl-Think-Short-Defense_updated.pptx
@@ -2595,12 +2595,12 @@
           <a:p>
             <a:pPr algn="l" indent="0" marL="0">
               <a:lnSpc>
-                <a:spcPts val="2100"/>
-              </a:lnSpc>
-              <a:buNone/>
-            </a:pPr>
-            <a:r>
-              <a:rPr lang="en-US" sz="1500" b="1" dirty="0">
+                <a:spcPts val="1820"/>
+              </a:lnSpc>
+              <a:buNone/>
+            </a:pPr>
+            <a:r>
+              <a:rPr lang="en-US" sz="1300" b="1" dirty="0">
                 <a:solidFill>
                   <a:srgbClr val="F4EFFF"/>
                 </a:solidFill>
@@ -2610,7 +2610,7 @@
               </a:rPr>
               <a:t>John Lorence B. Amarela · Christian B. Añez · Andrei H. Caldeo</a:t>
             </a:r>
-            <a:endParaRPr lang="en-US" sz="1500" dirty="0"/>
+            <a:endParaRPr lang="en-US" sz="1300" dirty="0"/>
           </a:p>
         </p:txBody>
       </p:sp>
@@ -2921,12 +2921,12 @@
           <a:p>
             <a:pPr algn="l" indent="0" marL="0">
               <a:lnSpc>
-                <a:spcPts val="1820"/>
-              </a:lnSpc>
-              <a:buNone/>
-            </a:pPr>
-            <a:r>
-              <a:rPr lang="en-US" sz="1300" b="1" spc="150" kern="0" dirty="0">
+                <a:spcPts val="1540"/>
+              </a:lnSpc>
+              <a:buNone/>
+            </a:pPr>
+            <a:r>
+              <a:rPr lang="en-US" sz="1050" b="1" spc="50" kern="0" dirty="0">
                 <a:solidFill>
                   <a:srgbClr val="CBA6F7"/>
                 </a:solidFill>
@@ -2936,7 +2936,7 @@
               </a:rPr>
               <a:t>SYSTEM CHARACTERISTICS</a:t>
             </a:r>
-            <a:endParaRPr lang="en-US" sz="1300" dirty="0"/>
+            <a:endParaRPr lang="en-US" sz="1050" dirty="0"/>
           </a:p>
         </p:txBody>
       </p:sp>
@@ -3053,12 +3053,12 @@
           <a:p>
             <a:pPr algn="l" indent="0" marL="0">
               <a:lnSpc>
-                <a:spcPts val="1690"/>
-              </a:lnSpc>
-              <a:buNone/>
-            </a:pPr>
-            <a:r>
-              <a:rPr lang="en-US" sz="1300" dirty="0">
+                <a:spcPts val="1560"/>
+              </a:lnSpc>
+              <a:buNone/>
+            </a:pPr>
+            <a:r>
+              <a:rPr lang="en-US" sz="1200" dirty="0">
                 <a:solidFill>
                   <a:srgbClr val="DDD6EE"/>
                 </a:solidFill>
@@ -3068,7 +3068,7 @@
               </a:rPr>
               <a:t>SD = 0.57. The highest-rated part of the whole questionnaire.</a:t>
             </a:r>
-            <a:endParaRPr lang="en-US" sz="1300" dirty="0"/>
+            <a:endParaRPr lang="en-US" sz="1200" dirty="0"/>
           </a:p>
         </p:txBody>
       </p:sp>
@@ -3124,12 +3124,12 @@
           <a:p>
             <a:pPr algn="l" indent="0" marL="0">
               <a:lnSpc>
-                <a:spcPts val="1495"/>
-              </a:lnSpc>
-              <a:buNone/>
-            </a:pPr>
-            <a:r>
-              <a:rPr lang="en-US" sz="1300" dirty="0">
+                <a:spcPts val="1322"/>
+              </a:lnSpc>
+              <a:buNone/>
+            </a:pPr>
+            <a:r>
+              <a:rPr lang="en-US" sz="1150" dirty="0">
                 <a:solidFill>
                   <a:srgbClr val="1B1430"/>
                 </a:solidFill>
@@ -3139,7 +3139,7 @@
               </a:rPr>
               <a:t>Mini games</a:t>
             </a:r>
-            <a:endParaRPr lang="en-US" sz="1300" dirty="0"/>
+            <a:endParaRPr lang="en-US" sz="1150" dirty="0"/>
           </a:p>
         </p:txBody>
       </p:sp>
@@ -3256,12 +3256,12 @@
           <a:p>
             <a:pPr algn="l" indent="0" marL="0">
               <a:lnSpc>
-                <a:spcPts val="1495"/>
-              </a:lnSpc>
-              <a:buNone/>
-            </a:pPr>
-            <a:r>
-              <a:rPr lang="en-US" sz="1300" dirty="0">
+                <a:spcPts val="1322"/>
+              </a:lnSpc>
+              <a:buNone/>
+            </a:pPr>
+            <a:r>
+              <a:rPr lang="en-US" sz="1150" dirty="0">
                 <a:solidFill>
                   <a:srgbClr val="1B1430"/>
                 </a:solidFill>
@@ -3271,7 +3271,7 @@
               </a:rPr>
               <a:t>Characters</a:t>
             </a:r>
-            <a:endParaRPr lang="en-US" sz="1300" dirty="0"/>
+            <a:endParaRPr lang="en-US" sz="1150" dirty="0"/>
           </a:p>
         </p:txBody>
       </p:sp>
@@ -3388,12 +3388,12 @@
           <a:p>
             <a:pPr algn="l" indent="0" marL="0">
               <a:lnSpc>
-                <a:spcPts val="1495"/>
-              </a:lnSpc>
-              <a:buNone/>
-            </a:pPr>
-            <a:r>
-              <a:rPr lang="en-US" sz="1300" dirty="0">
+                <a:spcPts val="1322"/>
+              </a:lnSpc>
+              <a:buNone/>
+            </a:pPr>
+            <a:r>
+              <a:rPr lang="en-US" sz="1150" dirty="0">
                 <a:solidFill>
                   <a:srgbClr val="1B1430"/>
                 </a:solidFill>
@@ -3403,7 +3403,7 @@
               </a:rPr>
               <a:t>Graphics and backgrounds</a:t>
             </a:r>
-            <a:endParaRPr lang="en-US" sz="1300" dirty="0"/>
+            <a:endParaRPr lang="en-US" sz="1150" dirty="0"/>
           </a:p>
         </p:txBody>
       </p:sp>
@@ -3520,12 +3520,12 @@
           <a:p>
             <a:pPr algn="l" indent="0" marL="0">
               <a:lnSpc>
-                <a:spcPts val="1495"/>
-              </a:lnSpc>
-              <a:buNone/>
-            </a:pPr>
-            <a:r>
-              <a:rPr lang="en-US" sz="1300" dirty="0">
+                <a:spcPts val="1322"/>
+              </a:lnSpc>
+              <a:buNone/>
+            </a:pPr>
+            <a:r>
+              <a:rPr lang="en-US" sz="1150" dirty="0">
                 <a:solidFill>
                   <a:srgbClr val="1B1430"/>
                 </a:solidFill>
@@ -3535,7 +3535,7 @@
               </a:rPr>
               <a:t>Story and situations</a:t>
             </a:r>
-            <a:endParaRPr lang="en-US" sz="1300" dirty="0"/>
+            <a:endParaRPr lang="en-US" sz="1150" dirty="0"/>
           </a:p>
         </p:txBody>
       </p:sp>
@@ -4278,7 +4278,7 @@
               <a:buNone/>
             </a:pPr>
             <a:r>
-              <a:rPr lang="en-US" sz="1300" b="1" spc="150" kern="0" dirty="0">
+              <a:rPr lang="en-US" sz="1050" b="1" spc="50" kern="0" dirty="0">
                 <a:solidFill>
                   <a:srgbClr val="CBA6F7"/>
                 </a:solidFill>
@@ -4288,7 +4288,7 @@
               </a:rPr>
               <a:t>OVERALL MEAN</a:t>
             </a:r>
-            <a:endParaRPr lang="en-US" sz="1300" dirty="0"/>
+            <a:endParaRPr lang="en-US" sz="1050" dirty="0"/>
           </a:p>
         </p:txBody>
       </p:sp>
@@ -4405,12 +4405,12 @@
           <a:p>
             <a:pPr algn="l" indent="0" marL="0">
               <a:lnSpc>
-                <a:spcPts val="1690"/>
-              </a:lnSpc>
-              <a:buNone/>
-            </a:pPr>
-            <a:r>
-              <a:rPr lang="en-US" sz="1300" dirty="0">
+                <a:spcPts val="1430"/>
+              </a:lnSpc>
+              <a:buNone/>
+            </a:pPr>
+            <a:r>
+              <a:rPr lang="en-US" sz="1100" dirty="0">
                 <a:solidFill>
                   <a:srgbClr val="DDD6EE"/>
                 </a:solidFill>
@@ -4420,7 +4420,7 @@
               </a:rPr>
               <a:t>All five constructs were interpreted as Agree, which means a high level of acceptance.</a:t>
             </a:r>
-            <a:endParaRPr lang="en-US" sz="1300" dirty="0"/>
+            <a:endParaRPr lang="en-US" sz="1100" dirty="0"/>
           </a:p>
         </p:txBody>
       </p:sp>
@@ -4476,12 +4476,12 @@
           <a:p>
             <a:pPr algn="l" indent="0" marL="0">
               <a:lnSpc>
-                <a:spcPts val="1495"/>
-              </a:lnSpc>
-              <a:buNone/>
-            </a:pPr>
-            <a:r>
-              <a:rPr lang="en-US" sz="1300" dirty="0">
+                <a:spcPts val="1380"/>
+              </a:lnSpc>
+              <a:buNone/>
+            </a:pPr>
+            <a:r>
+              <a:rPr lang="en-US" sz="1200" dirty="0">
                 <a:solidFill>
                   <a:srgbClr val="1B1430"/>
                 </a:solidFill>
@@ -4491,7 +4491,7 @@
               </a:rPr>
               <a:t>Perceived Ease of Use</a:t>
             </a:r>
-            <a:endParaRPr lang="en-US" sz="1300" dirty="0"/>
+            <a:endParaRPr lang="en-US" sz="1200" dirty="0"/>
           </a:p>
         </p:txBody>
       </p:sp>
@@ -4608,12 +4608,12 @@
           <a:p>
             <a:pPr algn="l" indent="0" marL="0">
               <a:lnSpc>
-                <a:spcPts val="1495"/>
-              </a:lnSpc>
-              <a:buNone/>
-            </a:pPr>
-            <a:r>
-              <a:rPr lang="en-US" sz="1300" dirty="0">
+                <a:spcPts val="1380"/>
+              </a:lnSpc>
+              <a:buNone/>
+            </a:pPr>
+            <a:r>
+              <a:rPr lang="en-US" sz="1200" dirty="0">
                 <a:solidFill>
                   <a:srgbClr val="1B1430"/>
                 </a:solidFill>
@@ -4623,7 +4623,7 @@
               </a:rPr>
               <a:t>Enjoyment and Engagement</a:t>
             </a:r>
-            <a:endParaRPr lang="en-US" sz="1300" dirty="0"/>
+            <a:endParaRPr lang="en-US" sz="1200" dirty="0"/>
           </a:p>
         </p:txBody>
       </p:sp>
@@ -4740,12 +4740,12 @@
           <a:p>
             <a:pPr algn="l" indent="0" marL="0">
               <a:lnSpc>
-                <a:spcPts val="1495"/>
-              </a:lnSpc>
-              <a:buNone/>
-            </a:pPr>
-            <a:r>
-              <a:rPr lang="en-US" sz="1300" dirty="0">
+                <a:spcPts val="1380"/>
+              </a:lnSpc>
+              <a:buNone/>
+            </a:pPr>
+            <a:r>
+              <a:rPr lang="en-US" sz="1200" dirty="0">
                 <a:solidFill>
                   <a:srgbClr val="1B1430"/>
                 </a:solidFill>
@@ -4755,7 +4755,7 @@
               </a:rPr>
               <a:t>Attitude Toward Using</a:t>
             </a:r>
-            <a:endParaRPr lang="en-US" sz="1300" dirty="0"/>
+            <a:endParaRPr lang="en-US" sz="1200" dirty="0"/>
           </a:p>
         </p:txBody>
       </p:sp>
@@ -4872,12 +4872,12 @@
           <a:p>
             <a:pPr algn="l" indent="0" marL="0">
               <a:lnSpc>
-                <a:spcPts val="1495"/>
-              </a:lnSpc>
-              <a:buNone/>
-            </a:pPr>
-            <a:r>
-              <a:rPr lang="en-US" sz="1300" dirty="0">
+                <a:spcPts val="1380"/>
+              </a:lnSpc>
+              <a:buNone/>
+            </a:pPr>
+            <a:r>
+              <a:rPr lang="en-US" sz="1200" dirty="0">
                 <a:solidFill>
                   <a:srgbClr val="1B1430"/>
                 </a:solidFill>
@@ -4887,7 +4887,7 @@
               </a:rPr>
               <a:t>Behavioral Intention</a:t>
             </a:r>
-            <a:endParaRPr lang="en-US" sz="1300" dirty="0"/>
+            <a:endParaRPr lang="en-US" sz="1200" dirty="0"/>
           </a:p>
         </p:txBody>
       </p:sp>
@@ -5004,12 +5004,12 @@
           <a:p>
             <a:pPr algn="l" indent="0" marL="0">
               <a:lnSpc>
-                <a:spcPts val="1495"/>
-              </a:lnSpc>
-              <a:buNone/>
-            </a:pPr>
-            <a:r>
-              <a:rPr lang="en-US" sz="1300" dirty="0">
+                <a:spcPts val="1380"/>
+              </a:lnSpc>
+              <a:buNone/>
+            </a:pPr>
+            <a:r>
+              <a:rPr lang="en-US" sz="1200" dirty="0">
                 <a:solidFill>
                   <a:srgbClr val="1B1430"/>
                 </a:solidFill>
@@ -5019,7 +5019,7 @@
               </a:rPr>
               <a:t>Perceived Usefulness</a:t>
             </a:r>
-            <a:endParaRPr lang="en-US" sz="1300" dirty="0"/>
+            <a:endParaRPr lang="en-US" sz="1200" dirty="0"/>
           </a:p>
         </p:txBody>
       </p:sp>
@@ -5412,12 +5412,12 @@
           <a:p>
             <a:pPr algn="l" indent="0" marL="0">
               <a:lnSpc>
-                <a:spcPts val="1820"/>
-              </a:lnSpc>
-              <a:buNone/>
-            </a:pPr>
-            <a:r>
-              <a:rPr lang="en-US" sz="1300" b="1" spc="150" kern="0" dirty="0">
+                <a:spcPts val="1610"/>
+              </a:lnSpc>
+              <a:buNone/>
+            </a:pPr>
+            <a:r>
+              <a:rPr lang="en-US" sz="1050" b="1" spc="50" kern="0" dirty="0">
                 <a:solidFill>
                   <a:srgbClr val="CBA6F7"/>
                 </a:solidFill>
@@ -5427,7 +5427,7 @@
               </a:rPr>
               <a:t>LEARNING AND FEEDBACK</a:t>
             </a:r>
-            <a:endParaRPr lang="en-US" sz="1300" dirty="0"/>
+            <a:endParaRPr lang="en-US" sz="1050" dirty="0"/>
           </a:p>
         </p:txBody>
       </p:sp>
@@ -5615,12 +5615,12 @@
           <a:p>
             <a:pPr algn="l" indent="0" marL="0">
               <a:lnSpc>
-                <a:spcPts val="1495"/>
-              </a:lnSpc>
-              <a:buNone/>
-            </a:pPr>
-            <a:r>
-              <a:rPr lang="en-US" sz="1300" dirty="0">
+                <a:spcPts val="1322"/>
+              </a:lnSpc>
+              <a:buNone/>
+            </a:pPr>
+            <a:r>
+              <a:rPr lang="en-US" sz="1150" dirty="0">
                 <a:solidFill>
                   <a:srgbClr val="1B1430"/>
                 </a:solidFill>
@@ -5630,7 +5630,7 @@
               </a:rPr>
               <a:t>Think critically about AI use</a:t>
             </a:r>
-            <a:endParaRPr lang="en-US" sz="1300" dirty="0"/>
+            <a:endParaRPr lang="en-US" sz="1150" dirty="0"/>
           </a:p>
         </p:txBody>
       </p:sp>
@@ -5747,12 +5747,12 @@
           <a:p>
             <a:pPr algn="l" indent="0" marL="0">
               <a:lnSpc>
-                <a:spcPts val="1495"/>
-              </a:lnSpc>
-              <a:buNone/>
-            </a:pPr>
-            <a:r>
-              <a:rPr lang="en-US" sz="1300" dirty="0">
+                <a:spcPts val="1322"/>
+              </a:lnSpc>
+              <a:buNone/>
+            </a:pPr>
+            <a:r>
+              <a:rPr lang="en-US" sz="1150" dirty="0">
                 <a:solidFill>
                   <a:srgbClr val="1B1430"/>
                 </a:solidFill>
@@ -5762,7 +5762,7 @@
               </a:rPr>
               <a:t>Understanding my own work matters</a:t>
             </a:r>
-            <a:endParaRPr lang="en-US" sz="1300" dirty="0"/>
+            <a:endParaRPr lang="en-US" sz="1150" dirty="0"/>
           </a:p>
         </p:txBody>
       </p:sp>
@@ -5879,12 +5879,12 @@
           <a:p>
             <a:pPr algn="l" indent="0" marL="0">
               <a:lnSpc>
-                <a:spcPts val="1495"/>
-              </a:lnSpc>
-              <a:buNone/>
-            </a:pPr>
-            <a:r>
-              <a:rPr lang="en-US" sz="1300" dirty="0">
+                <a:spcPts val="1323"/>
+              </a:lnSpc>
+              <a:buNone/>
+            </a:pPr>
+            <a:r>
+              <a:rPr lang="en-US" sz="1150" dirty="0">
                 <a:solidFill>
                   <a:srgbClr val="1B1430"/>
                 </a:solidFill>
@@ -5894,7 +5894,7 @@
               </a:rPr>
               <a:t>Can help other students reflect</a:t>
             </a:r>
-            <a:endParaRPr lang="en-US" sz="1300" dirty="0"/>
+            <a:endParaRPr lang="en-US" sz="1150" dirty="0"/>
           </a:p>
         </p:txBody>
       </p:sp>
@@ -6011,12 +6011,12 @@
           <a:p>
             <a:pPr algn="l" indent="0" marL="0">
               <a:lnSpc>
-                <a:spcPts val="1495"/>
-              </a:lnSpc>
-              <a:buNone/>
-            </a:pPr>
-            <a:r>
-              <a:rPr lang="en-US" sz="1300" dirty="0">
+                <a:spcPts val="1322"/>
+              </a:lnSpc>
+              <a:buNone/>
+            </a:pPr>
+            <a:r>
+              <a:rPr lang="en-US" sz="1150" dirty="0">
                 <a:solidFill>
                   <a:srgbClr val="1B1430"/>
                 </a:solidFill>
@@ -6026,7 +6026,7 @@
               </a:rPr>
               <a:t>Achieved its educational purpose</a:t>
             </a:r>
-            <a:endParaRPr lang="en-US" sz="1300" dirty="0"/>
+            <a:endParaRPr lang="en-US" sz="1150" dirty="0"/>
           </a:p>
         </p:txBody>
       </p:sp>
@@ -6143,12 +6143,12 @@
           <a:p>
             <a:pPr algn="l" indent="0" marL="0">
               <a:lnSpc>
-                <a:spcPts val="1495"/>
-              </a:lnSpc>
-              <a:buNone/>
-            </a:pPr>
-            <a:r>
-              <a:rPr lang="en-US" sz="1300" dirty="0">
+                <a:spcPts val="1322"/>
+              </a:lnSpc>
+              <a:buNone/>
+            </a:pPr>
+            <a:r>
+              <a:rPr lang="en-US" sz="1150" dirty="0">
                 <a:solidFill>
                   <a:srgbClr val="1B1430"/>
                 </a:solidFill>
@@ -6158,7 +6158,7 @@
               </a:rPr>
               <a:t>Aware of risks of AI dependency</a:t>
             </a:r>
-            <a:endParaRPr lang="en-US" sz="1300" dirty="0"/>
+            <a:endParaRPr lang="en-US" sz="1150" dirty="0"/>
           </a:p>
         </p:txBody>
       </p:sp>
@@ -6284,12 +6284,12 @@
           <a:p>
             <a:pPr algn="l" indent="0" marL="0">
               <a:lnSpc>
-                <a:spcPts val="1890"/>
-              </a:lnSpc>
-              <a:buNone/>
-            </a:pPr>
-            <a:r>
-              <a:rPr lang="en-US" sz="1400" b="1" dirty="0">
+                <a:spcPts val="1552"/>
+              </a:lnSpc>
+              <a:buNone/>
+            </a:pPr>
+            <a:r>
+              <a:rPr lang="en-US" sz="1150" b="1" dirty="0">
                 <a:solidFill>
                   <a:srgbClr val="5A3A00"/>
                 </a:solidFill>
@@ -6300,7 +6300,7 @@
               <a:t>Keep in mind:</a:t>
             </a:r>
             <a:r>
-              <a:rPr lang="en-US" sz="1400" dirty="0">
+              <a:rPr lang="en-US" sz="1150" dirty="0">
                 <a:solidFill>
                   <a:srgbClr val="5A3A00"/>
                 </a:solidFill>
@@ -6310,7 +6310,7 @@
               </a:rPr>
               <a:t> these are self-reported perceptions after one play. They show what students felt, not a measured change in behavior.</a:t>
             </a:r>
-            <a:endParaRPr lang="en-US" sz="1400" dirty="0"/>
+            <a:endParaRPr lang="en-US" sz="1150" dirty="0"/>
           </a:p>
         </p:txBody>
       </p:sp>
@@ -6664,12 +6664,12 @@
           <a:p>
             <a:pPr algn="l" indent="0" marL="0">
               <a:lnSpc>
-                <a:spcPts val="1890"/>
-              </a:lnSpc>
-              <a:buNone/>
-            </a:pPr>
-            <a:r>
-              <a:rPr lang="en-US" sz="1400" dirty="0">
+                <a:spcPts val="1822"/>
+              </a:lnSpc>
+              <a:buNone/>
+            </a:pPr>
+            <a:r>
+              <a:rPr lang="en-US" sz="1350" dirty="0">
                 <a:solidFill>
                   <a:srgbClr val="3D3358"/>
                 </a:solidFill>
@@ -6679,7 +6679,7 @@
               </a:rPr>
               <a:t>Ctrl + Think shows AI dependency through branching routes, characters, decisions and 2D art.</a:t>
             </a:r>
-            <a:endParaRPr lang="en-US" sz="1400" dirty="0"/>
+            <a:endParaRPr lang="en-US" sz="1350" dirty="0"/>
           </a:p>
         </p:txBody>
       </p:sp>
@@ -6823,12 +6823,12 @@
           <a:p>
             <a:pPr algn="l" indent="0" marL="0">
               <a:lnSpc>
-                <a:spcPts val="1890"/>
-              </a:lnSpc>
-              <a:buNone/>
-            </a:pPr>
-            <a:r>
-              <a:rPr lang="en-US" sz="1400" dirty="0">
+                <a:spcPts val="1822"/>
+              </a:lnSpc>
+              <a:buNone/>
+            </a:pPr>
+            <a:r>
+              <a:rPr lang="en-US" sz="1350" dirty="0">
                 <a:solidFill>
                   <a:srgbClr val="3D3358"/>
                 </a:solidFill>
@@ -6838,7 +6838,7 @@
               </a:rPr>
               <a:t>Learning and feedback scored 3.63 (Agree). Results are self-reported, not measured behavior change.</a:t>
             </a:r>
-            <a:endParaRPr lang="en-US" sz="1400" dirty="0"/>
+            <a:endParaRPr lang="en-US" sz="1350" dirty="0"/>
           </a:p>
         </p:txBody>
       </p:sp>
@@ -6982,12 +6982,12 @@
           <a:p>
             <a:pPr algn="l" indent="0" marL="0">
               <a:lnSpc>
-                <a:spcPts val="1890"/>
-              </a:lnSpc>
-              <a:buNone/>
-            </a:pPr>
-            <a:r>
-              <a:rPr lang="en-US" sz="1400" dirty="0">
+                <a:spcPts val="1822"/>
+              </a:lnSpc>
+              <a:buNone/>
+            </a:pPr>
+            <a:r>
+              <a:rPr lang="en-US" sz="1350" dirty="0">
                 <a:solidFill>
                   <a:srgbClr val="3D3358"/>
                 </a:solidFill>
@@ -6997,7 +6997,7 @@
               </a:rPr>
               <a:t>All five TAM constructs were Agree, with an overall mean of 3.73 and Good reliability (0.873).</a:t>
             </a:r>
-            <a:endParaRPr lang="en-US" sz="1400" dirty="0"/>
+            <a:endParaRPr lang="en-US" sz="1350" dirty="0"/>
           </a:p>
         </p:txBody>
       </p:sp>
@@ -7810,12 +7810,12 @@
           <a:p>
             <a:pPr algn="l" indent="0" marL="0">
               <a:lnSpc>
-                <a:spcPts val="2133"/>
-              </a:lnSpc>
-              <a:buNone/>
-            </a:pPr>
-            <a:r>
-              <a:rPr lang="en-US" sz="1580" dirty="0">
+                <a:spcPts val="1863"/>
+              </a:lnSpc>
+              <a:buNone/>
+            </a:pPr>
+            <a:r>
+              <a:rPr lang="en-US" sz="1400" dirty="0">
                 <a:solidFill>
                   <a:srgbClr val="DDD6EE"/>
                 </a:solidFill>
@@ -7825,7 +7825,7 @@
               </a:rPr>
               <a:t>ChatGPT and Google Gemini are free to everyone. Students use them to brainstorm, summarize sources, write essays and solve problem sets, which saves time and effort.</a:t>
             </a:r>
-            <a:endParaRPr lang="en-US" sz="1580" dirty="0"/>
+            <a:endParaRPr lang="en-US" sz="1400" dirty="0"/>
           </a:p>
         </p:txBody>
       </p:sp>
@@ -7948,12 +7948,12 @@
           <a:p>
             <a:pPr algn="l" indent="0" marL="0">
               <a:lnSpc>
-                <a:spcPts val="2160"/>
-              </a:lnSpc>
-              <a:buNone/>
-            </a:pPr>
-            <a:r>
-              <a:rPr lang="en-US" sz="1600" dirty="0">
+                <a:spcPts val="1890"/>
+              </a:lnSpc>
+              <a:buNone/>
+            </a:pPr>
+            <a:r>
+              <a:rPr lang="en-US" sz="1400" dirty="0">
                 <a:solidFill>
                   <a:srgbClr val="DDD6EE"/>
                 </a:solidFill>
@@ -7963,7 +7963,7 @@
               </a:rPr>
               <a:t>Over-reliance leads to cognitive offloading. Critical thinking, creativity and analysis are not fully developed when AI does the complex thinking for the student.</a:t>
             </a:r>
-            <a:endParaRPr lang="en-US" sz="1600" dirty="0"/>
+            <a:endParaRPr lang="en-US" sz="1400" dirty="0"/>
           </a:p>
         </p:txBody>
       </p:sp>
@@ -8086,12 +8086,12 @@
           <a:p>
             <a:pPr algn="l" indent="0" marL="0">
               <a:lnSpc>
-                <a:spcPts val="2160"/>
-              </a:lnSpc>
-              <a:buNone/>
-            </a:pPr>
-            <a:r>
-              <a:rPr lang="en-US" sz="1600" dirty="0">
+                <a:spcPts val="1890"/>
+              </a:lnSpc>
+              <a:buNone/>
+            </a:pPr>
+            <a:r>
+              <a:rPr lang="en-US" sz="1400" dirty="0">
                 <a:solidFill>
                   <a:srgbClr val="DDD6EE"/>
                 </a:solidFill>
@@ -8101,7 +8101,7 @@
               </a:rPr>
               <a:t>Most school responses limit or detect AI use. Few tools help students see how harmful over-reliance can be, and few target Filipino college students.</a:t>
             </a:r>
-            <a:endParaRPr lang="en-US" sz="1600" dirty="0"/>
+            <a:endParaRPr lang="en-US" sz="1400" dirty="0"/>
           </a:p>
         </p:txBody>
       </p:sp>
@@ -8406,12 +8406,12 @@
           <a:p>
             <a:pPr algn="l" indent="0" marL="0">
               <a:lnSpc>
-                <a:spcPts val="2340"/>
-              </a:lnSpc>
-              <a:buNone/>
-            </a:pPr>
-            <a:r>
-              <a:rPr lang="en-US" sz="1800" b="1" dirty="0">
+                <a:spcPts val="1885"/>
+              </a:lnSpc>
+              <a:buNone/>
+            </a:pPr>
+            <a:r>
+              <a:rPr lang="en-US" sz="1450" b="1" dirty="0">
                 <a:solidFill>
                   <a:srgbClr val="F4EFFF"/>
                 </a:solidFill>
@@ -8422,7 +8422,7 @@
               <a:t>General objective:</a:t>
             </a:r>
             <a:r>
-              <a:rPr lang="en-US" sz="1800" dirty="0">
+              <a:rPr lang="en-US" sz="1450" dirty="0">
                 <a:solidFill>
                   <a:srgbClr val="F4EFFF"/>
                 </a:solidFill>
@@ -8432,7 +8432,7 @@
               </a:rPr>
               <a:t> develop an interactive visual novel that highlights AI dependency among college students.</a:t>
             </a:r>
-            <a:endParaRPr lang="en-US" sz="1800" dirty="0"/>
+            <a:endParaRPr lang="en-US" sz="1450" dirty="0"/>
           </a:p>
         </p:txBody>
       </p:sp>
@@ -8576,12 +8576,12 @@
           <a:p>
             <a:pPr algn="l" indent="0" marL="0">
               <a:lnSpc>
-                <a:spcPts val="1950"/>
-              </a:lnSpc>
-              <a:buNone/>
-            </a:pPr>
-            <a:r>
-              <a:rPr lang="en-US" sz="1500" dirty="0">
+                <a:spcPts val="1625"/>
+              </a:lnSpc>
+              <a:buNone/>
+            </a:pPr>
+            <a:r>
+              <a:rPr lang="en-US" sz="1250" dirty="0">
                 <a:solidFill>
                   <a:srgbClr val="DDD6EE"/>
                 </a:solidFill>
@@ -8591,7 +8591,7 @@
               </a:rPr>
               <a:t>Create a visual novel that shows the process and impact of relying on AI through story branches, character interactions, player decisions and 2D graphics.</a:t>
             </a:r>
-            <a:endParaRPr lang="en-US" sz="1500" dirty="0"/>
+            <a:endParaRPr lang="en-US" sz="1250" dirty="0"/>
           </a:p>
         </p:txBody>
       </p:sp>
@@ -8735,12 +8735,12 @@
           <a:p>
             <a:pPr algn="l" indent="0" marL="0">
               <a:lnSpc>
-                <a:spcPts val="1950"/>
-              </a:lnSpc>
-              <a:buNone/>
-            </a:pPr>
-            <a:r>
-              <a:rPr lang="en-US" sz="1500" dirty="0">
+                <a:spcPts val="1625"/>
+              </a:lnSpc>
+              <a:buNone/>
+            </a:pPr>
+            <a:r>
+              <a:rPr lang="en-US" sz="1250" dirty="0">
                 <a:solidFill>
                   <a:srgbClr val="DDD6EE"/>
                 </a:solidFill>
@@ -8750,7 +8750,7 @@
               </a:rPr>
               <a:t>Assess whether the game supports self-reflection and responsible AI use, balancing AI assistance with a student’s own thinking.</a:t>
             </a:r>
-            <a:endParaRPr lang="en-US" sz="1500" dirty="0"/>
+            <a:endParaRPr lang="en-US" sz="1250" dirty="0"/>
           </a:p>
         </p:txBody>
       </p:sp>
@@ -8894,12 +8894,12 @@
           <a:p>
             <a:pPr algn="l" indent="0" marL="0">
               <a:lnSpc>
-                <a:spcPts val="1950"/>
-              </a:lnSpc>
-              <a:buNone/>
-            </a:pPr>
-            <a:r>
-              <a:rPr lang="en-US" sz="1500" dirty="0">
+                <a:spcPts val="1625"/>
+              </a:lnSpc>
+              <a:buNone/>
+            </a:pPr>
+            <a:r>
+              <a:rPr lang="en-US" sz="1250" dirty="0">
                 <a:solidFill>
                   <a:srgbClr val="DDD6EE"/>
                 </a:solidFill>
@@ -8909,7 +8909,7 @@
               </a:rPr>
               <a:t>Assess usability and learning efficacy with the Technology Acceptance Model (TAM): usefulness, ease of use, enjoyment, attitude and intention.</a:t>
             </a:r>
-            <a:endParaRPr lang="en-US" sz="1500" dirty="0"/>
+            <a:endParaRPr lang="en-US" sz="1250" dirty="0"/>
           </a:p>
         </p:txBody>
       </p:sp>
@@ -8938,12 +8938,12 @@
           <a:p>
             <a:pPr algn="l" indent="0" marL="0">
               <a:lnSpc>
-                <a:spcPts val="1960"/>
-              </a:lnSpc>
-              <a:buNone/>
-            </a:pPr>
-            <a:r>
-              <a:rPr lang="en-US" sz="1400" b="1" dirty="0">
+                <a:spcPts val="1610"/>
+              </a:lnSpc>
+              <a:buNone/>
+            </a:pPr>
+            <a:r>
+              <a:rPr lang="en-US" sz="1150" b="1" dirty="0">
                 <a:solidFill>
                   <a:srgbClr val="A99FC6"/>
                 </a:solidFill>
@@ -8953,7 +8953,7 @@
               </a:rPr>
               <a:t>Aligned with</a:t>
             </a:r>
-            <a:endParaRPr lang="en-US" sz="1400" dirty="0"/>
+            <a:endParaRPr lang="en-US" sz="1150" dirty="0"/>
           </a:p>
         </p:txBody>
       </p:sp>
@@ -8986,12 +8986,12 @@
           <a:p>
             <a:pPr algn="ctr" indent="0" marL="0">
               <a:lnSpc>
-                <a:spcPts val="1960"/>
-              </a:lnSpc>
-              <a:buNone/>
-            </a:pPr>
-            <a:r>
-              <a:rPr lang="en-US" sz="1400" b="1" dirty="0">
+                <a:spcPts val="1610"/>
+              </a:lnSpc>
+              <a:buNone/>
+            </a:pPr>
+            <a:r>
+              <a:rPr lang="en-US" sz="1150" b="1" dirty="0">
                 <a:solidFill>
                   <a:srgbClr val="1B1430"/>
                 </a:solidFill>
@@ -9001,7 +9001,7 @@
               </a:rPr>
               <a:t>SDG 4 · Quality Education</a:t>
             </a:r>
-            <a:endParaRPr lang="en-US" sz="1400" dirty="0"/>
+            <a:endParaRPr lang="en-US" sz="1150" dirty="0"/>
           </a:p>
         </p:txBody>
       </p:sp>
@@ -9034,12 +9034,12 @@
           <a:p>
             <a:pPr algn="ctr" indent="0" marL="0">
               <a:lnSpc>
-                <a:spcPts val="1960"/>
-              </a:lnSpc>
-              <a:buNone/>
-            </a:pPr>
-            <a:r>
-              <a:rPr lang="en-US" sz="1400" b="1" dirty="0">
+                <a:spcPts val="1610"/>
+              </a:lnSpc>
+              <a:buNone/>
+            </a:pPr>
+            <a:r>
+              <a:rPr lang="en-US" sz="1150" b="1" dirty="0">
                 <a:solidFill>
                   <a:srgbClr val="1B1430"/>
                 </a:solidFill>
@@ -9049,7 +9049,7 @@
               </a:rPr>
               <a:t>SDG 9 · Industry, Innovation and Infrastructure</a:t>
             </a:r>
-            <a:endParaRPr lang="en-US" sz="1400" dirty="0"/>
+            <a:endParaRPr lang="en-US" sz="1150" dirty="0"/>
           </a:p>
         </p:txBody>
       </p:sp>
@@ -9359,12 +9359,12 @@
           <a:p>
             <a:pPr algn="l" indent="0" marL="0">
               <a:lnSpc>
-                <a:spcPts val="1690"/>
-              </a:lnSpc>
-              <a:buNone/>
-            </a:pPr>
-            <a:r>
-              <a:rPr lang="en-US" sz="1300" b="1" dirty="0">
+                <a:spcPts val="1560"/>
+              </a:lnSpc>
+              <a:buNone/>
+            </a:pPr>
+            <a:r>
+              <a:rPr lang="en-US" sz="1200" b="1" dirty="0">
                 <a:solidFill>
                   <a:srgbClr val="CBA6F7"/>
                 </a:solidFill>
@@ -9375,7 +9375,7 @@
               <a:t>System:</a:t>
             </a:r>
             <a:r>
-              <a:rPr lang="en-US" sz="1300" dirty="0">
+              <a:rPr lang="en-US" sz="1200" dirty="0">
                 <a:solidFill>
                   <a:srgbClr val="DDD6EE"/>
                 </a:solidFill>
@@ -9385,7 +9385,7 @@
               </a:rPr>
               <a:t> story, characters, graphics, mini games</a:t>
             </a:r>
-            <a:endParaRPr lang="en-US" sz="1300" dirty="0"/>
+            <a:endParaRPr lang="en-US" sz="1200" dirty="0"/>
           </a:p>
         </p:txBody>
       </p:sp>
@@ -9519,12 +9519,12 @@
           <a:p>
             <a:pPr algn="l" indent="0" marL="0">
               <a:lnSpc>
-                <a:spcPts val="2100"/>
-              </a:lnSpc>
-              <a:buNone/>
-            </a:pPr>
-            <a:r>
-              <a:rPr lang="en-US" sz="1500" b="1" dirty="0">
+                <a:spcPts val="1960"/>
+              </a:lnSpc>
+              <a:buNone/>
+            </a:pPr>
+            <a:r>
+              <a:rPr lang="en-US" sz="1400" b="1" dirty="0">
                 <a:solidFill>
                   <a:srgbClr val="F4EFFF"/>
                 </a:solidFill>
@@ -9534,7 +9534,7 @@
               </a:rPr>
               <a:t>Perceived Usefulness</a:t>
             </a:r>
-            <a:endParaRPr lang="en-US" sz="1500" dirty="0"/>
+            <a:endParaRPr lang="en-US" sz="1400" dirty="0"/>
           </a:p>
         </p:txBody>
       </p:sp>
@@ -9634,12 +9634,12 @@
           <a:p>
             <a:pPr algn="l" indent="0" marL="0">
               <a:lnSpc>
-                <a:spcPts val="2100"/>
-              </a:lnSpc>
-              <a:buNone/>
-            </a:pPr>
-            <a:r>
-              <a:rPr lang="en-US" sz="1500" b="1" dirty="0">
+                <a:spcPts val="1960"/>
+              </a:lnSpc>
+              <a:buNone/>
+            </a:pPr>
+            <a:r>
+              <a:rPr lang="en-US" sz="1400" b="1" dirty="0">
                 <a:solidFill>
                   <a:srgbClr val="F4EFFF"/>
                 </a:solidFill>
@@ -9649,7 +9649,7 @@
               </a:rPr>
               <a:t>Perceived Ease of Use</a:t>
             </a:r>
-            <a:endParaRPr lang="en-US" sz="1500" dirty="0"/>
+            <a:endParaRPr lang="en-US" sz="1400" dirty="0"/>
           </a:p>
         </p:txBody>
       </p:sp>
@@ -9749,12 +9749,12 @@
           <a:p>
             <a:pPr algn="l" indent="0" marL="0">
               <a:lnSpc>
-                <a:spcPts val="2100"/>
-              </a:lnSpc>
-              <a:buNone/>
-            </a:pPr>
-            <a:r>
-              <a:rPr lang="en-US" sz="1500" b="1" dirty="0">
+                <a:spcPts val="1960"/>
+              </a:lnSpc>
+              <a:buNone/>
+            </a:pPr>
+            <a:r>
+              <a:rPr lang="en-US" sz="1400" b="1" dirty="0">
                 <a:solidFill>
                   <a:srgbClr val="F2C179"/>
                 </a:solidFill>
@@ -9764,7 +9764,7 @@
               </a:rPr>
               <a:t>Enjoyment and Engagement</a:t>
             </a:r>
-            <a:endParaRPr lang="en-US" sz="1500" dirty="0"/>
+            <a:endParaRPr lang="en-US" sz="1400" dirty="0"/>
           </a:p>
         </p:txBody>
       </p:sp>
@@ -9887,12 +9887,12 @@
           <a:p>
             <a:pPr algn="l" indent="0" marL="0">
               <a:lnSpc>
-                <a:spcPts val="2240"/>
-              </a:lnSpc>
-              <a:buNone/>
-            </a:pPr>
-            <a:r>
-              <a:rPr lang="en-US" sz="1600" b="1" dirty="0">
+                <a:spcPts val="1960"/>
+              </a:lnSpc>
+              <a:buNone/>
+            </a:pPr>
+            <a:r>
+              <a:rPr lang="en-US" sz="1400" b="1" dirty="0">
                 <a:solidFill>
                   <a:srgbClr val="F4EFFF"/>
                 </a:solidFill>
@@ -9902,7 +9902,7 @@
               </a:rPr>
               <a:t>Attitude Toward Using</a:t>
             </a:r>
-            <a:endParaRPr lang="en-US" sz="1600" dirty="0"/>
+            <a:endParaRPr lang="en-US" sz="1400" dirty="0"/>
           </a:p>
         </p:txBody>
       </p:sp>
@@ -10020,12 +10020,12 @@
           <a:p>
             <a:pPr algn="l" indent="0" marL="0">
               <a:lnSpc>
-                <a:spcPts val="2240"/>
-              </a:lnSpc>
-              <a:buNone/>
-            </a:pPr>
-            <a:r>
-              <a:rPr lang="en-US" sz="1600" b="1" dirty="0">
+                <a:spcPts val="1960"/>
+              </a:lnSpc>
+              <a:buNone/>
+            </a:pPr>
+            <a:r>
+              <a:rPr lang="en-US" sz="1400" b="1" dirty="0">
                 <a:solidFill>
                   <a:srgbClr val="1B1430"/>
                 </a:solidFill>
@@ -10035,7 +10035,7 @@
               </a:rPr>
               <a:t>Behavioral Intention</a:t>
             </a:r>
-            <a:endParaRPr lang="en-US" sz="1600" dirty="0"/>
+            <a:endParaRPr lang="en-US" sz="1400" dirty="0"/>
           </a:p>
         </p:txBody>
       </p:sp>
@@ -10064,12 +10064,12 @@
           <a:p>
             <a:pPr algn="l" indent="0" marL="0">
               <a:lnSpc>
-                <a:spcPts val="1820"/>
-              </a:lnSpc>
-              <a:buNone/>
-            </a:pPr>
-            <a:r>
-              <a:rPr lang="en-US" sz="1300" dirty="0">
+                <a:spcPts val="1470"/>
+              </a:lnSpc>
+              <a:buNone/>
+            </a:pPr>
+            <a:r>
+              <a:rPr lang="en-US" sz="1050" dirty="0">
                 <a:solidFill>
                   <a:srgbClr val="2D2150"/>
                 </a:solidFill>
@@ -10079,7 +10079,7 @@
               </a:rPr>
               <a:t>Play again, recommend, accept</a:t>
             </a:r>
-            <a:endParaRPr lang="en-US" sz="1300" dirty="0"/>
+            <a:endParaRPr lang="en-US" sz="1050" dirty="0"/>
           </a:p>
         </p:txBody>
       </p:sp>
@@ -10571,12 +10571,12 @@
           <a:p>
             <a:pPr algn="l" indent="0" marL="0">
               <a:lnSpc>
-                <a:spcPts val="1960"/>
-              </a:lnSpc>
-              <a:buNone/>
-            </a:pPr>
-            <a:r>
-              <a:rPr lang="en-US" sz="1400" b="1" dirty="0">
+                <a:spcPts val="1540"/>
+              </a:lnSpc>
+              <a:buNone/>
+            </a:pPr>
+            <a:r>
+              <a:rPr lang="en-US" sz="1100" b="1" dirty="0">
                 <a:solidFill>
                   <a:srgbClr val="DDD6EE"/>
                 </a:solidFill>
@@ -10586,7 +10586,7 @@
               </a:rPr>
               <a:t>Chapters plus a Free Day</a:t>
             </a:r>
-            <a:endParaRPr lang="en-US" sz="1400" dirty="0"/>
+            <a:endParaRPr lang="en-US" sz="1100" dirty="0"/>
           </a:p>
         </p:txBody>
       </p:sp>
@@ -11439,12 +11439,12 @@
           <a:p>
             <a:pPr algn="l" indent="0" marL="0">
               <a:lnSpc>
-                <a:spcPts val="1820"/>
-              </a:lnSpc>
-              <a:buNone/>
-            </a:pPr>
-            <a:r>
-              <a:rPr lang="en-US" sz="1400" b="1" dirty="0">
+                <a:spcPts val="1495"/>
+              </a:lnSpc>
+              <a:buNone/>
+            </a:pPr>
+            <a:r>
+              <a:rPr lang="en-US" sz="1150" b="1" dirty="0">
                 <a:solidFill>
                   <a:srgbClr val="3D3358"/>
                 </a:solidFill>
@@ -11455,7 +11455,7 @@
               <a:t>Message:</a:t>
             </a:r>
             <a:r>
-              <a:rPr lang="en-US" sz="1400" dirty="0">
+              <a:rPr lang="en-US" sz="1150" dirty="0">
                 <a:solidFill>
                   <a:srgbClr val="3D3358"/>
                 </a:solidFill>
@@ -11465,7 +11465,7 @@
               </a:rPr>
               <a:t> AI is a tool, not a replacement.</a:t>
             </a:r>
-            <a:endParaRPr lang="en-US" sz="1400" dirty="0"/>
+            <a:endParaRPr lang="en-US" sz="1150" dirty="0"/>
           </a:p>
         </p:txBody>
       </p:sp>
@@ -12054,12 +12054,12 @@
           <a:p>
             <a:pPr algn="l" indent="0" marL="0">
               <a:lnSpc>
-                <a:spcPts val="1890"/>
-              </a:lnSpc>
-              <a:buNone/>
-            </a:pPr>
-            <a:r>
-              <a:rPr lang="en-US" sz="1400" dirty="0">
+                <a:spcPts val="1755"/>
+              </a:lnSpc>
+              <a:buNone/>
+            </a:pPr>
+            <a:r>
+              <a:rPr lang="en-US" sz="1300" dirty="0">
                 <a:solidFill>
                   <a:srgbClr val="3D3358"/>
                 </a:solidFill>
@@ -12069,7 +12069,7 @@
               </a:rPr>
               <a:t>A hidden dependency score rises with every AI shortcut and decides the ending. The player never sees the number while playing.</a:t>
             </a:r>
-            <a:endParaRPr lang="en-US" sz="1400" dirty="0"/>
+            <a:endParaRPr lang="en-US" sz="1300" dirty="0"/>
           </a:p>
         </p:txBody>
       </p:sp>
@@ -14084,7 +14084,7 @@
               <a:buNone/>
             </a:pPr>
             <a:r>
-              <a:rPr lang="en-US" sz="1300" b="1" spc="150" kern="0" dirty="0">
+              <a:rPr lang="en-US" sz="1050" b="1" spc="50" kern="0" dirty="0">
                 <a:solidFill>
                   <a:srgbClr val="CBA6F7"/>
                 </a:solidFill>
@@ -14094,7 +14094,7 @@
               </a:rPr>
               <a:t>COMPOSITE MEAN</a:t>
             </a:r>
-            <a:endParaRPr lang="en-US" sz="1300" dirty="0"/>
+            <a:endParaRPr lang="en-US" sz="1050" dirty="0"/>
           </a:p>
         </p:txBody>
       </p:sp>
@@ -14282,12 +14282,12 @@
           <a:p>
             <a:pPr algn="l" indent="0" marL="0">
               <a:lnSpc>
-                <a:spcPts val="1495"/>
-              </a:lnSpc>
-              <a:buNone/>
-            </a:pPr>
-            <a:r>
-              <a:rPr lang="en-US" sz="1300" dirty="0">
+                <a:spcPts val="1265"/>
+              </a:lnSpc>
+              <a:buNone/>
+            </a:pPr>
+            <a:r>
+              <a:rPr lang="en-US" sz="1100" dirty="0">
                 <a:solidFill>
                   <a:srgbClr val="1B1430"/>
                 </a:solidFill>
@@ -14297,7 +14297,7 @@
               </a:rPr>
               <a:t>Rely on AI for academic tasks</a:t>
             </a:r>
-            <a:endParaRPr lang="en-US" sz="1300" dirty="0"/>
+            <a:endParaRPr lang="en-US" sz="1100" dirty="0"/>
           </a:p>
         </p:txBody>
       </p:sp>
@@ -14414,12 +14414,12 @@
           <a:p>
             <a:pPr algn="l" indent="0" marL="0">
               <a:lnSpc>
-                <a:spcPts val="1495"/>
-              </a:lnSpc>
-              <a:buNone/>
-            </a:pPr>
-            <a:r>
-              <a:rPr lang="en-US" sz="1300" dirty="0">
+                <a:spcPts val="1265"/>
+              </a:lnSpc>
+              <a:buNone/>
+            </a:pPr>
+            <a:r>
+              <a:rPr lang="en-US" sz="1100" dirty="0">
                 <a:solidFill>
                   <a:srgbClr val="1B1430"/>
                 </a:solidFill>
@@ -14429,7 +14429,7 @@
               </a:rPr>
               <a:t>Hard to finish tasks without AI</a:t>
             </a:r>
-            <a:endParaRPr lang="en-US" sz="1300" dirty="0"/>
+            <a:endParaRPr lang="en-US" sz="1100" dirty="0"/>
           </a:p>
         </p:txBody>
       </p:sp>
@@ -14546,12 +14546,12 @@
           <a:p>
             <a:pPr algn="l" indent="0" marL="0">
               <a:lnSpc>
-                <a:spcPts val="1495"/>
-              </a:lnSpc>
-              <a:buNone/>
-            </a:pPr>
-            <a:r>
-              <a:rPr lang="en-US" sz="1300" dirty="0">
+                <a:spcPts val="1265"/>
+              </a:lnSpc>
+              <a:buNone/>
+            </a:pPr>
+            <a:r>
+              <a:rPr lang="en-US" sz="1100" dirty="0">
                 <a:solidFill>
                   <a:srgbClr val="1B1430"/>
                 </a:solidFill>
@@ -14561,7 +14561,7 @@
               </a:rPr>
               <a:t>Accept answers without checking</a:t>
             </a:r>
-            <a:endParaRPr lang="en-US" sz="1300" dirty="0"/>
+            <a:endParaRPr lang="en-US" sz="1100" dirty="0"/>
           </a:p>
         </p:txBody>
       </p:sp>
@@ -14678,12 +14678,12 @@
           <a:p>
             <a:pPr algn="l" indent="0" marL="0">
               <a:lnSpc>
-                <a:spcPts val="1495"/>
-              </a:lnSpc>
-              <a:buNone/>
-            </a:pPr>
-            <a:r>
-              <a:rPr lang="en-US" sz="1300" dirty="0">
+                <a:spcPts val="1265"/>
+              </a:lnSpc>
+              <a:buNone/>
+            </a:pPr>
+            <a:r>
+              <a:rPr lang="en-US" sz="1100" dirty="0">
                 <a:solidFill>
                   <a:srgbClr val="1B1430"/>
                 </a:solidFill>
@@ -14693,7 +14693,7 @@
               </a:rPr>
               <a:t>Use answers I do not understand</a:t>
             </a:r>
-            <a:endParaRPr lang="en-US" sz="1300" dirty="0"/>
+            <a:endParaRPr lang="en-US" sz="1100" dirty="0"/>
           </a:p>
         </p:txBody>
       </p:sp>
@@ -14810,12 +14810,12 @@
           <a:p>
             <a:pPr algn="l" indent="0" marL="0">
               <a:lnSpc>
-                <a:spcPts val="1495"/>
-              </a:lnSpc>
-              <a:buNone/>
-            </a:pPr>
-            <a:r>
-              <a:rPr lang="en-US" sz="1300" dirty="0">
+                <a:spcPts val="1265"/>
+              </a:lnSpc>
+              <a:buNone/>
+            </a:pPr>
+            <a:r>
+              <a:rPr lang="en-US" sz="1100" dirty="0">
                 <a:solidFill>
                   <a:srgbClr val="1B1430"/>
                 </a:solidFill>
@@ -14825,7 +14825,7 @@
               </a:rPr>
               <a:t>Depend on AI instead of trying</a:t>
             </a:r>
-            <a:endParaRPr lang="en-US" sz="1300" dirty="0"/>
+            <a:endParaRPr lang="en-US" sz="1100" dirty="0"/>
           </a:p>
         </p:txBody>
       </p:sp>
@@ -14942,12 +14942,12 @@
           <a:p>
             <a:pPr algn="l" indent="0" marL="0">
               <a:lnSpc>
-                <a:spcPts val="1495"/>
-              </a:lnSpc>
-              <a:buNone/>
-            </a:pPr>
-            <a:r>
-              <a:rPr lang="en-US" sz="1300" dirty="0">
+                <a:spcPts val="1265"/>
+              </a:lnSpc>
+              <a:buNone/>
+            </a:pPr>
+            <a:r>
+              <a:rPr lang="en-US" sz="1100" dirty="0">
                 <a:solidFill>
                   <a:srgbClr val="1B1430"/>
                 </a:solidFill>
@@ -14957,7 +14957,7 @@
               </a:rPr>
               <a:t>Verify AI information</a:t>
             </a:r>
-            <a:endParaRPr lang="en-US" sz="1300" dirty="0"/>
+            <a:endParaRPr lang="en-US" sz="1100" dirty="0"/>
           </a:p>
         </p:txBody>
       </p:sp>
@@ -15074,12 +15074,12 @@
           <a:p>
             <a:pPr algn="l" indent="0" marL="0">
               <a:lnSpc>
-                <a:spcPts val="1495"/>
-              </a:lnSpc>
-              <a:buNone/>
-            </a:pPr>
-            <a:r>
-              <a:rPr lang="en-US" sz="1300" dirty="0">
+                <a:spcPts val="1265"/>
+              </a:lnSpc>
+              <a:buNone/>
+            </a:pPr>
+            <a:r>
+              <a:rPr lang="en-US" sz="1100" dirty="0">
                 <a:solidFill>
                   <a:srgbClr val="1B1430"/>
                 </a:solidFill>
@@ -15089,7 +15089,7 @@
               </a:rPr>
               <a:t>Own critical thinking matters</a:t>
             </a:r>
-            <a:endParaRPr lang="en-US" sz="1300" dirty="0"/>
+            <a:endParaRPr lang="en-US" sz="1100" dirty="0"/>
           </a:p>
         </p:txBody>
       </p:sp>

</xml_diff>